<commit_message>
Remove egg watermark from days 1-8 pieces
</commit_message>
<xml_diff>
--- a/Dia-3/Carrusel Como Guardar Huevos - FB 1080x1080.pptx
+++ b/Dia-3/Carrusel Como Guardar Huevos - FB 1080x1080.pptx
@@ -3103,52 +3103,6 @@
       <p:grpSpPr/>
       <p:sp>
         <p:nvSpPr>
-          <p:cNvPr id="2" name="Oval 1"/>
-          <p:cNvSpPr/>
-          <p:nvPr/>
-        </p:nvSpPr>
-        <p:spPr>
-          <a:xfrm>
-            <a:off x="4518051" y="2874172"/>
-            <a:ext cx="6748272" cy="8637788"/>
-          </a:xfrm>
-          <a:prstGeom prst="ellipse">
-            <a:avLst/>
-          </a:prstGeom>
-          <a:solidFill>
-            <a:srgbClr val="14181F">
-              <a:alpha val="16000"/>
-            </a:srgbClr>
-          </a:solidFill>
-          <a:ln>
-            <a:noFill/>
-          </a:ln>
-          <a:effectLst/>
-        </p:spPr>
-        <p:style>
-          <a:lnRef idx="1">
-            <a:schemeClr val="accent1"/>
-          </a:lnRef>
-          <a:fillRef idx="3">
-            <a:schemeClr val="accent1"/>
-          </a:fillRef>
-          <a:effectRef idx="2">
-            <a:schemeClr val="accent1"/>
-          </a:effectRef>
-          <a:fontRef idx="minor">
-            <a:schemeClr val="lt1"/>
-          </a:fontRef>
-        </p:style>
-        <p:txBody>
-          <a:bodyPr rtlCol="0" anchor="ctr"/>
-          <a:lstStyle/>
-          <a:p>
-            <a:pPr algn="ctr"/>
-          </a:p>
-        </p:txBody>
-      </p:sp>
-      <p:sp>
-        <p:nvSpPr>
           <p:cNvPr id="3" name="TextBox 2"/>
           <p:cNvSpPr txBox="1"/>
           <p:nvPr/>
@@ -3978,52 +3932,6 @@
         <p:nvPr/>
       </p:nvGrpSpPr>
       <p:grpSpPr/>
-      <p:sp>
-        <p:nvSpPr>
-          <p:cNvPr id="2" name="Oval 1"/>
-          <p:cNvSpPr/>
-          <p:nvPr/>
-        </p:nvSpPr>
-        <p:spPr>
-          <a:xfrm>
-            <a:off x="-3036722" y="-2936847"/>
-            <a:ext cx="6748272" cy="8637788"/>
-          </a:xfrm>
-          <a:prstGeom prst="ellipse">
-            <a:avLst/>
-          </a:prstGeom>
-          <a:solidFill>
-            <a:srgbClr val="14181F">
-              <a:alpha val="16000"/>
-            </a:srgbClr>
-          </a:solidFill>
-          <a:ln>
-            <a:noFill/>
-          </a:ln>
-          <a:effectLst/>
-        </p:spPr>
-        <p:style>
-          <a:lnRef idx="1">
-            <a:schemeClr val="accent1"/>
-          </a:lnRef>
-          <a:fillRef idx="3">
-            <a:schemeClr val="accent1"/>
-          </a:fillRef>
-          <a:effectRef idx="2">
-            <a:schemeClr val="accent1"/>
-          </a:effectRef>
-          <a:fontRef idx="minor">
-            <a:schemeClr val="lt1"/>
-          </a:fontRef>
-        </p:style>
-        <p:txBody>
-          <a:bodyPr rtlCol="0" anchor="ctr"/>
-          <a:lstStyle/>
-          <a:p>
-            <a:pPr algn="ctr"/>
-          </a:p>
-        </p:txBody>
-      </p:sp>
       <p:sp>
         <p:nvSpPr>
           <p:cNvPr id="3" name="Rectangle 2"/>

</xml_diff>